<commit_message>
BPP submission: separate figures, ASCII sanitise, address reviewer checklist
- Remove embedded figures from bpp_manuscript_en.docx; captions only in back matter per Cambridge BPP guidance.

- Expand ASCII sanitisation for Office XML (>=, <=, x, punctuation, theme fonts).

- Align reference-list authors with in-text abbreviations for JOCS-CP and JMSR.

- Correct Introduction specialty example to data-included field.

- Regenerate all BPP docx/pptx/zip outputs from make all pipeline.

Co-Authored-By: Tatsuki Onishi <bougtoir@gmail.com>
</commit_message>
<xml_diff>
--- a/medical_accident_its_analysis/manuscript/bpp_figures.pptx
+++ b/medical_accident_its_analysis/manuscript/bpp_figures.pptx
@@ -333,7 +333,7 @@
           <a:p>
             <a:fld id="{C1FF6DA9-008F-8B48-92A6-B652298478BF}" type="slidenum">
               <a:rPr lang="en-US" smtClean="0"/>
-              <a:t>‹#›</a:t>
+              <a:t>#</a:t>
             </a:fld>
             <a:endParaRPr lang="en-US"/>
           </a:p>
@@ -503,7 +503,7 @@
           <a:p>
             <a:fld id="{C1FF6DA9-008F-8B48-92A6-B652298478BF}" type="slidenum">
               <a:rPr lang="en-US" smtClean="0"/>
-              <a:t>‹#›</a:t>
+              <a:t>#</a:t>
             </a:fld>
             <a:endParaRPr lang="en-US"/>
           </a:p>
@@ -683,7 +683,7 @@
           <a:p>
             <a:fld id="{C1FF6DA9-008F-8B48-92A6-B652298478BF}" type="slidenum">
               <a:rPr lang="en-US" smtClean="0"/>
-              <a:t>‹#›</a:t>
+              <a:t>#</a:t>
             </a:fld>
             <a:endParaRPr lang="en-US"/>
           </a:p>
@@ -853,7 +853,7 @@
           <a:p>
             <a:fld id="{C1FF6DA9-008F-8B48-92A6-B652298478BF}" type="slidenum">
               <a:rPr lang="en-US" smtClean="0"/>
-              <a:t>‹#›</a:t>
+              <a:t>#</a:t>
             </a:fld>
             <a:endParaRPr lang="en-US"/>
           </a:p>
@@ -1099,7 +1099,7 @@
           <a:p>
             <a:fld id="{C1FF6DA9-008F-8B48-92A6-B652298478BF}" type="slidenum">
               <a:rPr lang="en-US" smtClean="0"/>
-              <a:t>‹#›</a:t>
+              <a:t>#</a:t>
             </a:fld>
             <a:endParaRPr lang="en-US"/>
           </a:p>
@@ -1387,7 +1387,7 @@
           <a:p>
             <a:fld id="{C1FF6DA9-008F-8B48-92A6-B652298478BF}" type="slidenum">
               <a:rPr lang="en-US" smtClean="0"/>
-              <a:t>‹#›</a:t>
+              <a:t>#</a:t>
             </a:fld>
             <a:endParaRPr lang="en-US"/>
           </a:p>
@@ -1809,7 +1809,7 @@
           <a:p>
             <a:fld id="{C1FF6DA9-008F-8B48-92A6-B652298478BF}" type="slidenum">
               <a:rPr lang="en-US" smtClean="0"/>
-              <a:t>‹#›</a:t>
+              <a:t>#</a:t>
             </a:fld>
             <a:endParaRPr lang="en-US"/>
           </a:p>
@@ -1927,7 +1927,7 @@
           <a:p>
             <a:fld id="{C1FF6DA9-008F-8B48-92A6-B652298478BF}" type="slidenum">
               <a:rPr lang="en-US" smtClean="0"/>
-              <a:t>‹#›</a:t>
+              <a:t>#</a:t>
             </a:fld>
             <a:endParaRPr lang="en-US"/>
           </a:p>
@@ -2022,7 +2022,7 @@
           <a:p>
             <a:fld id="{C1FF6DA9-008F-8B48-92A6-B652298478BF}" type="slidenum">
               <a:rPr lang="en-US" smtClean="0"/>
-              <a:t>‹#›</a:t>
+              <a:t>#</a:t>
             </a:fld>
             <a:endParaRPr lang="en-US"/>
           </a:p>
@@ -2299,7 +2299,7 @@
           <a:p>
             <a:fld id="{C1FF6DA9-008F-8B48-92A6-B652298478BF}" type="slidenum">
               <a:rPr lang="en-US" smtClean="0"/>
-              <a:t>‹#›</a:t>
+              <a:t>#</a:t>
             </a:fld>
             <a:endParaRPr lang="en-US"/>
           </a:p>
@@ -2552,7 +2552,7 @@
           <a:p>
             <a:fld id="{C1FF6DA9-008F-8B48-92A6-B652298478BF}" type="slidenum">
               <a:rPr lang="en-US" smtClean="0"/>
-              <a:t>‹#›</a:t>
+              <a:t>#</a:t>
             </a:fld>
             <a:endParaRPr lang="en-US"/>
           </a:p>
@@ -2801,7 +2801,7 @@
           <a:p>
             <a:fld id="{C1FF6DA9-008F-8B48-92A6-B652298478BF}" type="slidenum">
               <a:rPr lang="en-US" smtClean="0"/>
-              <a:t>‹#›</a:t>
+              <a:t>#</a:t>
             </a:fld>
             <a:endParaRPr lang="en-US"/>
           </a:p>
@@ -2851,7 +2851,7 @@
           <a:spcPct val="20000"/>
         </a:spcBef>
         <a:buFont typeface="Arial"/>
-        <a:buChar char="•"/>
+        <a:buChar char="*"/>
         <a:defRPr sz="3200" kern="1200">
           <a:solidFill>
             <a:schemeClr val="tx1"/>
@@ -2866,7 +2866,7 @@
           <a:spcPct val="20000"/>
         </a:spcBef>
         <a:buFont typeface="Arial"/>
-        <a:buChar char="–"/>
+        <a:buChar char="-"/>
         <a:defRPr sz="2800" kern="1200">
           <a:solidFill>
             <a:schemeClr val="tx1"/>
@@ -2881,7 +2881,7 @@
           <a:spcPct val="20000"/>
         </a:spcBef>
         <a:buFont typeface="Arial"/>
-        <a:buChar char="•"/>
+        <a:buChar char="*"/>
         <a:defRPr sz="2400" kern="1200">
           <a:solidFill>
             <a:schemeClr val="tx1"/>
@@ -2896,7 +2896,7 @@
           <a:spcPct val="20000"/>
         </a:spcBef>
         <a:buFont typeface="Arial"/>
-        <a:buChar char="–"/>
+        <a:buChar char="-"/>
         <a:defRPr sz="2000" kern="1200">
           <a:solidFill>
             <a:schemeClr val="tx1"/>
@@ -2911,7 +2911,7 @@
           <a:spcPct val="20000"/>
         </a:spcBef>
         <a:buFont typeface="Arial"/>
-        <a:buChar char="»"/>
+        <a:buChar char="&gt;&gt;"/>
         <a:defRPr sz="2000" kern="1200">
           <a:solidFill>
             <a:schemeClr val="tx1"/>
@@ -2926,7 +2926,7 @@
           <a:spcPct val="20000"/>
         </a:spcBef>
         <a:buFont typeface="Arial"/>
-        <a:buChar char="•"/>
+        <a:buChar char="*"/>
         <a:defRPr sz="2000" kern="1200">
           <a:solidFill>
             <a:schemeClr val="tx1"/>
@@ -2941,7 +2941,7 @@
           <a:spcPct val="20000"/>
         </a:spcBef>
         <a:buFont typeface="Arial"/>
-        <a:buChar char="•"/>
+        <a:buChar char="*"/>
         <a:defRPr sz="2000" kern="1200">
           <a:solidFill>
             <a:schemeClr val="tx1"/>
@@ -2956,7 +2956,7 @@
           <a:spcPct val="20000"/>
         </a:spcBef>
         <a:buFont typeface="Arial"/>
-        <a:buChar char="•"/>
+        <a:buChar char="*"/>
         <a:defRPr sz="2000" kern="1200">
           <a:solidFill>
             <a:schemeClr val="tx1"/>
@@ -2971,7 +2971,7 @@
           <a:spcPct val="20000"/>
         </a:spcBef>
         <a:buFont typeface="Arial"/>
-        <a:buChar char="•"/>
+        <a:buChar char="*"/>
         <a:defRPr sz="2000" kern="1200">
           <a:solidFill>
             <a:schemeClr val="tx1"/>
@@ -3527,10 +3527,10 @@
         <a:latin typeface="Calibri"/>
         <a:ea typeface=""/>
         <a:cs typeface=""/>
-        <a:font script="Jpan" typeface="ＭＳ Ｐゴシック"/>
-        <a:font script="Hang" typeface="맑은 고딕"/>
-        <a:font script="Hans" typeface="宋体"/>
-        <a:font script="Hant" typeface="新細明體"/>
+        <a:font script="Jpan" typeface="MS PGothic"/>
+        <a:font script="Hang" typeface="Malgun Gothic"/>
+        <a:font script="Hans" typeface="SimSun"/>
+        <a:font script="Hant" typeface="PMingLiU"/>
         <a:font script="Arab" typeface="Times New Roman"/>
         <a:font script="Hebr" typeface="Times New Roman"/>
         <a:font script="Thai" typeface="Angsana New"/>
@@ -3562,10 +3562,10 @@
         <a:latin typeface="Calibri"/>
         <a:ea typeface=""/>
         <a:cs typeface=""/>
-        <a:font script="Jpan" typeface="ＭＳ Ｐゴシック"/>
-        <a:font script="Hang" typeface="맑은 고딕"/>
-        <a:font script="Hans" typeface="宋体"/>
-        <a:font script="Hant" typeface="新細明體"/>
+        <a:font script="Jpan" typeface="MS PGothic"/>
+        <a:font script="Hang" typeface="Malgun Gothic"/>
+        <a:font script="Hans" typeface="SimSun"/>
+        <a:font script="Hant" typeface="PMingLiU"/>
         <a:font script="Arab" typeface="Arial"/>
         <a:font script="Hebr" typeface="Arial"/>
         <a:font script="Thai" typeface="Cordia New"/>

</xml_diff>